<commit_message>
enregistrement des analyses sous un nom, chaîne d'ingestion regroupée dans services/ingestion, mise en forme du css et doc à jour
</commit_message>
<xml_diff>
--- a/docs/soutenance.pptx
+++ b/docs/soutenance.pptx
@@ -5399,7 +5399,7 @@
                 </a:solidFill>
                 <a:latin typeface="Consolas"/>
               </a:rPr>
-              <a:t>GET/POST /</a:t>
+              <a:t>+ admin.py</a:t>
             </a:r>
           </a:p>
           <a:p>
@@ -5443,7 +5443,7 @@
                 </a:solidFill>
                 <a:latin typeface="Consolas"/>
               </a:rPr>
-              <a:t>    ├── document.py   </a:t>
+              <a:t>    ├── ingestion/document.py     </a:t>
             </a:r>
             <a:r>
               <a:rPr sz="1162" b="0" i="0">
@@ -5474,7 +5474,7 @@
                 </a:solidFill>
                 <a:latin typeface="Consolas"/>
               </a:rPr>
-              <a:t>    ├── </a:t>
+              <a:t>    ├── ingestion/</a:t>
             </a:r>
             <a:r>
               <a:rPr sz="1162" b="0" i="0">
@@ -5669,7 +5669,7 @@
                 </a:solidFill>
                 <a:latin typeface="Consolas"/>
               </a:rPr>
-              <a:t>données par langue</a:t>
+              <a:t>listes lues en base</a:t>
             </a:r>
           </a:p>
           <a:p>
@@ -5861,7 +5861,7 @@
                 </a:solidFill>
                 <a:latin typeface="Segoe UI"/>
               </a:rPr>
-              <a:t>Le décorateur @enregistrer range une instance de la règle dans _registre au moment de l’import. fr.py et en.py remplissent le même registre : le moteur, lui, ne connaît aucune langue.</a:t>
+              <a:t>La liste REGLES énumère en clair une instance de chaque règle : ce que le moteur exécute se lit d’un coup d’œil, sans décorateur ni import caché. Le moteur, lui, ne connaît aucune langue.</a:t>
             </a:r>
           </a:p>
         </p:txBody>
@@ -5973,7 +5973,7 @@
                 </a:solidFill>
                 <a:latin typeface="Segoe UI"/>
               </a:rPr>
-              <a:t>Chaque règle déclare langues = ("fr",). run(document) écarte celles qui ne répondent pas, exécute les autres, puis trie les signalements par position — le surlignage exige un texte parcouru de gauche à droite.</a:t>
+              <a:t>Chaque règle sait si elle s’applique : par sa donnée, ou par langues = ("fr",). run(document) écarte les autres, exécute le reste, puis trie les signalements par position — le surlignage parcourt le texte de gauche à droite.</a:t>
             </a:r>
           </a:p>
         </p:txBody>
@@ -6090,7 +6090,7 @@
                 </a:solidFill>
                 <a:latin typeface="Consolas"/>
               </a:rPr>
-              <a:t> _registre:</a:t>
+              <a:t> REGLES:</a:t>
             </a:r>
           </a:p>
           <a:p>

</xml_diff>